<commit_message>
Refactor to IMDS-only trigger: act only on Redeploy/Reboot, remove Resource Health
- controller: narrow ACTIONABLE_EVENTS to {Reboot, Redeploy}; enrich store report
  with notBefore + description
- operator: refactor to a pure-stdlib IMDS-fed store/dedup/dashboard hub (no
  Resource Health polling, no subscription list, no Kubernetes API calls); ingest
  controller reports via /events and upsert+dedup
- manifests: drop Resource Health / subscription ConfigMaps, operator RBAC, and
  pip install; operator is now pure stdlib
- demos: remove demo-hardware.ps1 and demo-falsepositive.ps1 (Resource Health
  false-positive guardrails are moot under IMDS); add demo-reboot.ps1
- docs + deck: rewrite README, runbook, script, and slides to the IMDS-only
  Redeploy/Reboot story; frame Resource Health as awareness-only/excluded

Co-authored-by: Copilot <223556219+Copilot@users.noreply.github.com>
Copilot-Session: cba5c0e8-c9e5-44f8-ac6b-f4fe3c1117eb
</commit_message>
<xml_diff>
--- a/AKS-Maintenance-Handling.pptx
+++ b/AKS-Maintenance-Handling.pptx
@@ -3332,7 +3332,7 @@
                 <a:ea typeface="Segoe UI" pitchFamily="34" charset="-122"/>
                 <a:cs typeface="Segoe UI" pitchFamily="34" charset="-120"/>
               </a:rPr>
-              <a:t>ARM view of a resource’s availability — great for alerting, noisy for automation</a:t>
+              <a:t>ARM view of a resource’s availability — for alerting only; excluded as an automation trigger (noisy on scale-in)</a:t>
             </a:r>
             <a:endParaRPr lang="en-US" sz="1050" dirty="0"/>
           </a:p>
@@ -4685,7 +4685,7 @@
                 <a:ea typeface="Segoe UI" pitchFamily="34" charset="-122"/>
                 <a:cs typeface="Segoe UI" pitchFamily="34" charset="-120"/>
               </a:rPr>
-              <a:t>Poll maintenance signals across subscriptions</a:t>
+              <a:t>Poll maintenance signals (IMDS Scheduled Events)</a:t>
             </a:r>
             <a:endParaRPr lang="en-US" sz="1200" dirty="0"/>
           </a:p>
@@ -4783,7 +4783,7 @@
                 <a:ea typeface="Segoe UI" pitchFamily="34" charset="-122"/>
                 <a:cs typeface="Segoe UI" pitchFamily="34" charset="-120"/>
               </a:rPr>
-              <a:t>operator · subscription poller</a:t>
+              <a:t>controller · per-node IMDS</a:t>
             </a:r>
             <a:endParaRPr lang="en-US" sz="1150" dirty="0"/>
           </a:p>
@@ -5495,7 +5495,7 @@
                 <a:ea typeface="Segoe UI" pitchFamily="34" charset="-122"/>
                 <a:cs typeface="Segoe UI" pitchFamily="34" charset="-120"/>
               </a:rPr>
-              <a:t>Notify on hardware failures</a:t>
+              <a:t>Notify on maintenance actions (Reboot / Redeploy)</a:t>
             </a:r>
             <a:endParaRPr lang="en-US" sz="1200" dirty="0"/>
           </a:p>
@@ -5593,7 +5593,7 @@
                 <a:ea typeface="Segoe UI" pitchFamily="34" charset="-122"/>
                 <a:cs typeface="Segoe UI" pitchFamily="34" charset="-120"/>
               </a:rPr>
-              <a:t>operator → Logic App → Teams</a:t>
+              <a:t>controller → Logic App → Teams</a:t>
             </a:r>
             <a:endParaRPr lang="en-US" sz="1150" dirty="0"/>
           </a:p>
@@ -6416,7 +6416,7 @@
                 <a:ea typeface="Segoe UI" pitchFamily="34" charset="-122"/>
                 <a:cs typeface="Segoe UI" pitchFamily="34" charset="-120"/>
               </a:rPr>
-              <a:t>Show the cluster, node pool = VMSS, and the live Scheduled Events / Resource Health endpoints.</a:t>
+              <a:t>Show the cluster, node pool = VMSS, and the live Scheduled Events endpoint on a node.</a:t>
             </a:r>
             <a:endParaRPr lang="en-US" sz="1150" dirty="0"/>
           </a:p>
@@ -6884,7 +6884,7 @@
                 <a:ea typeface="Segoe UI Semibold" pitchFamily="34" charset="-122"/>
                 <a:cs typeface="Segoe UI Semibold" pitchFamily="34" charset="-120"/>
               </a:rPr>
-              <a:t>Hardware failure + alert</a:t>
+              <a:t>IMDS Reboot / Redeploy</a:t>
             </a:r>
             <a:endParaRPr lang="en-US" sz="1350" dirty="0"/>
           </a:p>
@@ -6923,7 +6923,7 @@
                 <a:ea typeface="Segoe UI" pitchFamily="34" charset="-122"/>
                 <a:cs typeface="Segoe UI" pitchFamily="34" charset="-120"/>
               </a:rPr>
-              <a:t>HardwareFailure → cordon + Teams card fires. demo-hardware.ps1</a:t>
+              <a:t>Reboot → cordon + drain + operator store + dedup. demo-reboot.ps1</a:t>
             </a:r>
             <a:endParaRPr lang="en-US" sz="1150" dirty="0"/>
           </a:p>
@@ -7686,7 +7686,7 @@
                 <a:ea typeface="Segoe UI" pitchFamily="34" charset="-122"/>
                 <a:cs typeface="Segoe UI" pitchFamily="34" charset="-120"/>
               </a:rPr>
-              <a:t>Scheduled Events &amp; Resource Health API calls</a:t>
+              <a:t>Scheduled Events API calls (IMDS)</a:t>
             </a:r>
             <a:endParaRPr lang="en-US" sz="1300" dirty="0"/>
           </a:p>
@@ -7923,27 +7923,6 @@
                 <a:cs typeface="Segoe UI" pitchFamily="34" charset="-120"/>
               </a:rPr>
               <a:t>The event content (we inject it via a ConfigMap instead of waiting hours for Azure to schedule real maintenance)</a:t>
-            </a:r>
-            <a:endParaRPr lang="en-US" sz="1300" dirty="0"/>
-          </a:p>
-          <a:p>
-            <a:pPr marL="203200" indent="-203200">
-              <a:spcAft>
-                <a:spcPts val="1200"/>
-              </a:spcAft>
-              <a:buSzPct val="100000"/>
-              <a:buChar char="•"/>
-            </a:pPr>
-            <a:r>
-              <a:rPr lang="en-US" sz="1300" dirty="0">
-                <a:solidFill>
-                  <a:srgbClr val="201F1E"/>
-                </a:solidFill>
-                <a:latin typeface="Segoe UI" pitchFamily="34" charset="0"/>
-                <a:ea typeface="Segoe UI" pitchFamily="34" charset="-122"/>
-                <a:cs typeface="Segoe UI" pitchFamily="34" charset="-120"/>
-              </a:rPr>
-              <a:t>The subscription-poll source list</a:t>
             </a:r>
             <a:endParaRPr lang="en-US" sz="1300" dirty="0"/>
           </a:p>
@@ -8427,7 +8406,7 @@
                 <a:ea typeface="Segoe UI Semibold" pitchFamily="34" charset="-122"/>
                 <a:cs typeface="Segoe UI Semibold" pitchFamily="34" charset="-120"/>
               </a:rPr>
-              <a:t>Real signal sources</a:t>
+              <a:t>Immutable images</a:t>
             </a:r>
             <a:endParaRPr lang="en-US" sz="1450" dirty="0"/>
           </a:p>
@@ -8466,7 +8445,7 @@
                 <a:ea typeface="Segoe UI" pitchFamily="34" charset="-122"/>
                 <a:cs typeface="Segoe UI" pitchFamily="34" charset="-120"/>
               </a:rPr>
-              <a:t>Point the operator poller at live Resource Health per subscription; keep Scheduled Events for the automation trigger.</a:t>
+              <a:t>Package the controller and operator as scanned container images in ACR — no pip-at-startup.</a:t>
             </a:r>
             <a:endParaRPr lang="en-US" sz="1150" dirty="0"/>
           </a:p>
@@ -9854,7 +9833,7 @@
                 <a:ea typeface="Segoe UI Semibold" pitchFamily="34" charset="-122"/>
                 <a:cs typeface="Segoe UI Semibold" pitchFamily="34" charset="-120"/>
               </a:rPr>
-              <a:t>Flip the poller to live Resource Health</a:t>
+              <a:t>Enable act mode</a:t>
             </a:r>
             <a:endParaRPr lang="en-US" sz="1500" dirty="0"/>
           </a:p>
@@ -9893,7 +9872,7 @@
                 <a:ea typeface="Segoe UI" pitchFamily="34" charset="-122"/>
                 <a:cs typeface="Segoe UI" pitchFamily="34" charset="-120"/>
               </a:rPr>
-              <a:t>Confirm what “Degraded” looks like in your environment and tune what we act on.</a:t>
+              <a:t>Move the controller from observe to act on your validated node pools, at your chosen lead time.</a:t>
             </a:r>
             <a:endParaRPr lang="en-US" sz="1200" dirty="0"/>
           </a:p>
@@ -15283,8 +15262,8 @@
         </p:nvSpPr>
         <p:spPr>
           <a:xfrm>
-            <a:off x="548640" y="1874520"/>
-            <a:ext cx="2377440" cy="868680"/>
+            <a:off x="548640" y="2377440"/>
+            <a:ext cx="2377440" cy="914400"/>
           </a:xfrm>
           <a:prstGeom prst="rect">
             <a:avLst/>
@@ -15308,8 +15287,8 @@
         </p:nvSpPr>
         <p:spPr>
           <a:xfrm>
-            <a:off x="685800" y="1947672"/>
-            <a:ext cx="2103120" cy="477774"/>
+            <a:off x="685800" y="2450592"/>
+            <a:ext cx="2103120" cy="502920"/>
           </a:xfrm>
           <a:prstGeom prst="rect">
             <a:avLst/>
@@ -15347,8 +15326,8 @@
         </p:nvSpPr>
         <p:spPr>
           <a:xfrm>
-            <a:off x="640080" y="2308860"/>
-            <a:ext cx="2194560" cy="434340"/>
+            <a:off x="640080" y="2834640"/>
+            <a:ext cx="2194560" cy="457200"/>
           </a:xfrm>
           <a:prstGeom prst="rect">
             <a:avLst/>
@@ -15376,144 +15355,58 @@
             </a:r>
             <a:endParaRPr lang="en-US" sz="900" dirty="0"/>
           </a:p>
-        </p:txBody>
-      </p:sp>
-      <p:sp>
-        <p:nvSpPr>
-          <p:cNvPr id="15" name="Shape 13"/>
-          <p:cNvSpPr/>
-          <p:nvPr/>
-        </p:nvSpPr>
-        <p:spPr>
-          <a:xfrm>
-            <a:off x="548640" y="2971800"/>
-            <a:ext cx="2377440" cy="868680"/>
-          </a:xfrm>
-          <a:prstGeom prst="rect">
-            <a:avLst/>
-          </a:prstGeom>
-          <a:solidFill>
-            <a:srgbClr val="605E5C"/>
-          </a:solidFill>
-          <a:ln w="12700">
-            <a:solidFill>
-              <a:srgbClr val="605E5C"/>
-            </a:solidFill>
-            <a:prstDash val="solid"/>
-          </a:ln>
-        </p:spPr>
-      </p:sp>
-      <p:sp>
-        <p:nvSpPr>
-          <p:cNvPr id="16" name="Text 14"/>
-          <p:cNvSpPr/>
-          <p:nvPr/>
-        </p:nvSpPr>
-        <p:spPr>
-          <a:xfrm>
-            <a:off x="685800" y="3044952"/>
-            <a:ext cx="2103120" cy="477774"/>
-          </a:xfrm>
-          <a:prstGeom prst="rect">
-            <a:avLst/>
-          </a:prstGeom>
-          <a:noFill/>
-          <a:ln/>
-        </p:spPr>
-        <p:txBody>
-          <a:bodyPr wrap="square" lIns="0" tIns="0" rIns="0" bIns="0" rtlCol="0" anchor="ctr"/>
-          <a:lstStyle/>
           <a:p>
             <a:pPr algn="ctr" indent="0" marL="0">
               <a:buNone/>
             </a:pPr>
             <a:r>
-              <a:rPr lang="en-US" sz="1250" b="1" dirty="0">
-                <a:solidFill>
-                  <a:srgbClr val="FFFFFF"/>
+              <a:rPr lang="en-US" sz="900" dirty="0">
+                <a:solidFill>
+                  <a:srgbClr val="DEECF9"/>
+                </a:solidFill>
+                <a:latin typeface="Segoe UI" pitchFamily="34" charset="0"/>
+                <a:ea typeface="Segoe UI" pitchFamily="34" charset="-122"/>
+                <a:cs typeface="Segoe UI" pitchFamily="34" charset="-120"/>
+              </a:rPr>
+              <a:t>Redeploy / Reboot only</a:t>
+            </a:r>
+            <a:endParaRPr lang="en-US" sz="900" dirty="0"/>
+          </a:p>
+        </p:txBody>
+      </p:sp>
+      <p:sp>
+        <p:nvSpPr>
+          <p:cNvPr id="15" name="Text 13"/>
+          <p:cNvSpPr/>
+          <p:nvPr/>
+        </p:nvSpPr>
+        <p:spPr>
+          <a:xfrm>
+            <a:off x="3977640" y="1554480"/>
+            <a:ext cx="4206240" cy="274320"/>
+          </a:xfrm>
+          <a:prstGeom prst="rect">
+            <a:avLst/>
+          </a:prstGeom>
+          <a:noFill/>
+          <a:ln/>
+        </p:spPr>
+        <p:txBody>
+          <a:bodyPr wrap="square" lIns="0" tIns="0" rIns="0" bIns="0" rtlCol="0" anchor="ctr"/>
+          <a:lstStyle/>
+          <a:p>
+            <a:pPr algn="ctr" indent="0" marL="0">
+              <a:buNone/>
+            </a:pPr>
+            <a:r>
+              <a:rPr lang="en-US" sz="1000" b="1" spc="150" kern="0" dirty="0">
+                <a:solidFill>
+                  <a:srgbClr val="605E5C"/>
                 </a:solidFill>
                 <a:latin typeface="Segoe UI Semibold" pitchFamily="34" charset="0"/>
                 <a:ea typeface="Segoe UI Semibold" pitchFamily="34" charset="-122"/>
                 <a:cs typeface="Segoe UI Semibold" pitchFamily="34" charset="-120"/>
               </a:rPr>
-              <a:t>Resource Health</a:t>
-            </a:r>
-            <a:endParaRPr lang="en-US" sz="1250" dirty="0"/>
-          </a:p>
-        </p:txBody>
-      </p:sp>
-      <p:sp>
-        <p:nvSpPr>
-          <p:cNvPr id="17" name="Text 15"/>
-          <p:cNvSpPr/>
-          <p:nvPr/>
-        </p:nvSpPr>
-        <p:spPr>
-          <a:xfrm>
-            <a:off x="640080" y="3406140"/>
-            <a:ext cx="2194560" cy="434340"/>
-          </a:xfrm>
-          <a:prstGeom prst="rect">
-            <a:avLst/>
-          </a:prstGeom>
-          <a:noFill/>
-          <a:ln/>
-        </p:spPr>
-        <p:txBody>
-          <a:bodyPr wrap="square" lIns="0" tIns="0" rIns="0" bIns="0" rtlCol="0" anchor="t"/>
-          <a:lstStyle/>
-          <a:p>
-            <a:pPr algn="ctr" indent="0" marL="0">
-              <a:buNone/>
-            </a:pPr>
-            <a:r>
-              <a:rPr lang="en-US" sz="900" dirty="0">
-                <a:solidFill>
-                  <a:srgbClr val="EDEBE9"/>
-                </a:solidFill>
-                <a:latin typeface="Segoe UI" pitchFamily="34" charset="0"/>
-                <a:ea typeface="Segoe UI" pitchFamily="34" charset="-122"/>
-                <a:cs typeface="Segoe UI" pitchFamily="34" charset="-120"/>
-              </a:rPr>
-              <a:t>ARM availabilityStatuses</a:t>
-            </a:r>
-            <a:endParaRPr lang="en-US" sz="900" dirty="0"/>
-          </a:p>
-        </p:txBody>
-      </p:sp>
-      <p:sp>
-        <p:nvSpPr>
-          <p:cNvPr id="18" name="Text 16"/>
-          <p:cNvSpPr/>
-          <p:nvPr/>
-        </p:nvSpPr>
-        <p:spPr>
-          <a:xfrm>
-            <a:off x="3977640" y="1554480"/>
-            <a:ext cx="4206240" cy="274320"/>
-          </a:xfrm>
-          <a:prstGeom prst="rect">
-            <a:avLst/>
-          </a:prstGeom>
-          <a:noFill/>
-          <a:ln/>
-        </p:spPr>
-        <p:txBody>
-          <a:bodyPr wrap="square" lIns="0" tIns="0" rIns="0" bIns="0" rtlCol="0" anchor="ctr"/>
-          <a:lstStyle/>
-          <a:p>
-            <a:pPr algn="ctr" indent="0" marL="0">
-              <a:buNone/>
-            </a:pPr>
-            <a:r>
-              <a:rPr lang="en-US" sz="1000" b="1" spc="150" kern="0" dirty="0">
-                <a:solidFill>
-                  <a:srgbClr val="605E5C"/>
-                </a:solidFill>
-                <a:latin typeface="Segoe UI Semibold" pitchFamily="34" charset="0"/>
-                <a:ea typeface="Segoe UI Semibold" pitchFamily="34" charset="-122"/>
-                <a:cs typeface="Segoe UI Semibold" pitchFamily="34" charset="-120"/>
-              </a:rPr>
               <a:t>ON THE CLUSTER</a:t>
             </a:r>
             <a:endParaRPr lang="en-US" sz="1000" dirty="0"/>
@@ -15522,7 +15415,7 @@
       </p:sp>
       <p:sp>
         <p:nvSpPr>
-          <p:cNvPr id="19" name="Shape 17"/>
+          <p:cNvPr id="16" name="Shape 14"/>
           <p:cNvSpPr/>
           <p:nvPr/>
         </p:nvSpPr>
@@ -15547,7 +15440,7 @@
       </p:sp>
       <p:sp>
         <p:nvSpPr>
-          <p:cNvPr id="20" name="Text 18"/>
+          <p:cNvPr id="17" name="Text 15"/>
           <p:cNvSpPr/>
           <p:nvPr/>
         </p:nvSpPr>
@@ -15586,7 +15479,7 @@
       </p:sp>
       <p:sp>
         <p:nvSpPr>
-          <p:cNvPr id="21" name="Text 19"/>
+          <p:cNvPr id="18" name="Text 16"/>
           <p:cNvSpPr/>
           <p:nvPr/>
         </p:nvSpPr>
@@ -15625,7 +15518,7 @@
       </p:sp>
       <p:sp>
         <p:nvSpPr>
-          <p:cNvPr id="22" name="Shape 20"/>
+          <p:cNvPr id="19" name="Shape 17"/>
           <p:cNvSpPr/>
           <p:nvPr/>
         </p:nvSpPr>
@@ -15650,7 +15543,7 @@
       </p:sp>
       <p:sp>
         <p:nvSpPr>
-          <p:cNvPr id="23" name="Text 21"/>
+          <p:cNvPr id="20" name="Text 18"/>
           <p:cNvSpPr/>
           <p:nvPr/>
         </p:nvSpPr>
@@ -15689,7 +15582,7 @@
       </p:sp>
       <p:sp>
         <p:nvSpPr>
-          <p:cNvPr id="24" name="Text 22"/>
+          <p:cNvPr id="21" name="Text 19"/>
           <p:cNvSpPr/>
           <p:nvPr/>
         </p:nvSpPr>
@@ -15720,7 +15613,7 @@
                 <a:ea typeface="Segoe UI" pitchFamily="34" charset="-122"/>
                 <a:cs typeface="Segoe UI" pitchFamily="34" charset="-120"/>
               </a:rPr>
-              <a:t>poll  ·  store  ·  dedup  ·  HW-notify  ·  dashboard</a:t>
+              <a:t>receive reports  ·  store  ·  dedup  ·  dashboard</a:t>
             </a:r>
             <a:endParaRPr lang="en-US" sz="900" dirty="0"/>
           </a:p>
@@ -15728,7 +15621,7 @@
       </p:sp>
       <p:sp>
         <p:nvSpPr>
-          <p:cNvPr id="25" name="Text 23"/>
+          <p:cNvPr id="22" name="Text 20"/>
           <p:cNvSpPr/>
           <p:nvPr/>
         </p:nvSpPr>
@@ -15767,7 +15660,7 @@
       </p:sp>
       <p:sp>
         <p:nvSpPr>
-          <p:cNvPr id="26" name="Shape 24"/>
+          <p:cNvPr id="23" name="Shape 21"/>
           <p:cNvSpPr/>
           <p:nvPr/>
         </p:nvSpPr>
@@ -15792,7 +15685,7 @@
       </p:sp>
       <p:sp>
         <p:nvSpPr>
-          <p:cNvPr id="27" name="Text 25"/>
+          <p:cNvPr id="24" name="Text 22"/>
           <p:cNvSpPr/>
           <p:nvPr/>
         </p:nvSpPr>
@@ -15831,7 +15724,7 @@
       </p:sp>
       <p:sp>
         <p:nvSpPr>
-          <p:cNvPr id="28" name="Shape 26"/>
+          <p:cNvPr id="25" name="Shape 23"/>
           <p:cNvSpPr/>
           <p:nvPr/>
         </p:nvSpPr>
@@ -15856,7 +15749,7 @@
       </p:sp>
       <p:sp>
         <p:nvSpPr>
-          <p:cNvPr id="29" name="Text 27"/>
+          <p:cNvPr id="26" name="Text 24"/>
           <p:cNvSpPr/>
           <p:nvPr/>
         </p:nvSpPr>
@@ -15895,7 +15788,7 @@
       </p:sp>
       <p:sp>
         <p:nvSpPr>
-          <p:cNvPr id="30" name="Text 28"/>
+          <p:cNvPr id="27" name="Text 25"/>
           <p:cNvSpPr/>
           <p:nvPr/>
         </p:nvSpPr>
@@ -15934,7 +15827,7 @@
       </p:sp>
       <p:sp>
         <p:nvSpPr>
-          <p:cNvPr id="31" name="Shape 29"/>
+          <p:cNvPr id="28" name="Shape 26"/>
           <p:cNvSpPr/>
           <p:nvPr/>
         </p:nvSpPr>
@@ -15959,7 +15852,7 @@
       </p:sp>
       <p:sp>
         <p:nvSpPr>
-          <p:cNvPr id="32" name="Text 30"/>
+          <p:cNvPr id="29" name="Text 27"/>
           <p:cNvSpPr/>
           <p:nvPr/>
         </p:nvSpPr>
@@ -15998,7 +15891,7 @@
       </p:sp>
       <p:sp>
         <p:nvSpPr>
-          <p:cNvPr id="33" name="Text 31"/>
+          <p:cNvPr id="30" name="Text 28"/>
           <p:cNvSpPr/>
           <p:nvPr/>
         </p:nvSpPr>
@@ -16037,14 +15930,14 @@
       </p:sp>
       <p:sp>
         <p:nvSpPr>
-          <p:cNvPr id="34" name="Shape 32"/>
-          <p:cNvSpPr/>
-          <p:nvPr/>
-        </p:nvSpPr>
-        <p:spPr>
-          <a:xfrm>
-            <a:off x="2926080" y="2304288"/>
-            <a:ext cx="1051560" cy="91440"/>
+          <p:cNvPr id="31" name="Shape 29"/>
+          <p:cNvSpPr/>
+          <p:nvPr/>
+        </p:nvSpPr>
+        <p:spPr>
+          <a:xfrm>
+            <a:off x="2926080" y="2788920"/>
+            <a:ext cx="1051560" cy="-365760"/>
           </a:xfrm>
           <a:prstGeom prst="line">
             <a:avLst/>
@@ -16061,14 +15954,14 @@
       </p:sp>
       <p:sp>
         <p:nvSpPr>
-          <p:cNvPr id="35" name="Shape 33"/>
-          <p:cNvSpPr/>
-          <p:nvPr/>
-        </p:nvSpPr>
-        <p:spPr>
-          <a:xfrm>
-            <a:off x="2926080" y="3401568"/>
-            <a:ext cx="1051560" cy="228600"/>
+          <p:cNvPr id="32" name="Shape 30"/>
+          <p:cNvSpPr/>
+          <p:nvPr/>
+        </p:nvSpPr>
+        <p:spPr>
+          <a:xfrm>
+            <a:off x="6080760" y="2926080"/>
+            <a:ext cx="0" cy="182880"/>
           </a:xfrm>
           <a:prstGeom prst="line">
             <a:avLst/>
@@ -16076,7 +15969,7 @@
           <a:noFill/>
           <a:ln w="25400">
             <a:solidFill>
-              <a:srgbClr val="605E5C"/>
+              <a:srgbClr val="0B2545"/>
             </a:solidFill>
             <a:prstDash val="solid"/>
             <a:tailEnd type="triangle"/>
@@ -16085,38 +15978,14 @@
       </p:sp>
       <p:sp>
         <p:nvSpPr>
-          <p:cNvPr id="36" name="Shape 34"/>
-          <p:cNvSpPr/>
-          <p:nvPr/>
-        </p:nvSpPr>
-        <p:spPr>
-          <a:xfrm>
-            <a:off x="6080760" y="3108960"/>
-            <a:ext cx="0" cy="-182880"/>
-          </a:xfrm>
-          <a:prstGeom prst="line">
-            <a:avLst/>
-          </a:prstGeom>
-          <a:noFill/>
-          <a:ln w="25400">
-            <a:solidFill>
-              <a:srgbClr val="FFB900"/>
-            </a:solidFill>
-            <a:prstDash val="solid"/>
-            <a:tailEnd type="triangle"/>
-          </a:ln>
-        </p:spPr>
-      </p:sp>
-      <p:sp>
-        <p:nvSpPr>
-          <p:cNvPr id="37" name="Text 35"/>
-          <p:cNvSpPr/>
-          <p:nvPr/>
-        </p:nvSpPr>
-        <p:spPr>
-          <a:xfrm>
-            <a:off x="6172200" y="2889504"/>
-            <a:ext cx="1828800" cy="274320"/>
+          <p:cNvPr id="33" name="Text 31"/>
+          <p:cNvSpPr/>
+          <p:nvPr/>
+        </p:nvSpPr>
+        <p:spPr>
+          <a:xfrm>
+            <a:off x="6172200" y="2907792"/>
+            <a:ext cx="1920240" cy="274320"/>
           </a:xfrm>
           <a:prstGeom prst="rect">
             <a:avLst/>
@@ -16140,7 +16009,7 @@
                 <a:ea typeface="Segoe UI" pitchFamily="34" charset="-122"/>
                 <a:cs typeface="Segoe UI" pitchFamily="34" charset="-120"/>
               </a:rPr>
-              <a:t>patch node-event CM</a:t>
+              <a:t>POST /events (report)</a:t>
             </a:r>
             <a:endParaRPr lang="en-US" sz="850" dirty="0"/>
           </a:p>
@@ -16148,14 +16017,14 @@
       </p:sp>
       <p:sp>
         <p:nvSpPr>
-          <p:cNvPr id="38" name="Shape 36"/>
-          <p:cNvSpPr/>
-          <p:nvPr/>
-        </p:nvSpPr>
-        <p:spPr>
-          <a:xfrm>
-            <a:off x="8183880" y="2331720"/>
-            <a:ext cx="1005840" cy="-91440"/>
+          <p:cNvPr id="34" name="Shape 32"/>
+          <p:cNvSpPr/>
+          <p:nvPr/>
+        </p:nvSpPr>
+        <p:spPr>
+          <a:xfrm>
+            <a:off x="8183880" y="2286000"/>
+            <a:ext cx="1005840" cy="-45720"/>
           </a:xfrm>
           <a:prstGeom prst="line">
             <a:avLst/>
@@ -16172,14 +16041,14 @@
       </p:sp>
       <p:sp>
         <p:nvSpPr>
-          <p:cNvPr id="39" name="Shape 37"/>
-          <p:cNvSpPr/>
-          <p:nvPr/>
-        </p:nvSpPr>
-        <p:spPr>
-          <a:xfrm>
-            <a:off x="8183880" y="3566160"/>
-            <a:ext cx="1005840" cy="-457200"/>
+          <p:cNvPr id="35" name="Shape 33"/>
+          <p:cNvSpPr/>
+          <p:nvPr/>
+        </p:nvSpPr>
+        <p:spPr>
+          <a:xfrm>
+            <a:off x="8183880" y="2651760"/>
+            <a:ext cx="1005840" cy="457200"/>
           </a:xfrm>
           <a:prstGeom prst="line">
             <a:avLst/>
@@ -16196,14 +16065,14 @@
       </p:sp>
       <p:sp>
         <p:nvSpPr>
-          <p:cNvPr id="40" name="Shape 38"/>
-          <p:cNvSpPr/>
-          <p:nvPr/>
-        </p:nvSpPr>
-        <p:spPr>
-          <a:xfrm>
-            <a:off x="8183880" y="3749040"/>
-            <a:ext cx="1005840" cy="228600"/>
+          <p:cNvPr id="36" name="Shape 34"/>
+          <p:cNvSpPr/>
+          <p:nvPr/>
+        </p:nvSpPr>
+        <p:spPr>
+          <a:xfrm>
+            <a:off x="8183880" y="3657600"/>
+            <a:ext cx="1005840" cy="320040"/>
           </a:xfrm>
           <a:prstGeom prst="line">
             <a:avLst/>
@@ -16220,7 +16089,7 @@
       </p:sp>
       <p:sp>
         <p:nvSpPr>
-          <p:cNvPr id="41" name="Shape 39"/>
+          <p:cNvPr id="37" name="Shape 35"/>
           <p:cNvSpPr/>
           <p:nvPr/>
         </p:nvSpPr>
@@ -16245,7 +16114,7 @@
       </p:sp>
       <p:sp>
         <p:nvSpPr>
-          <p:cNvPr id="42" name="Shape 40"/>
+          <p:cNvPr id="38" name="Shape 36"/>
           <p:cNvSpPr/>
           <p:nvPr/>
         </p:nvSpPr>
@@ -16265,7 +16134,7 @@
       </p:sp>
       <p:sp>
         <p:nvSpPr>
-          <p:cNvPr id="43" name="Text 41"/>
+          <p:cNvPr id="39" name="Text 37"/>
           <p:cNvSpPr/>
           <p:nvPr/>
         </p:nvSpPr>
@@ -16324,7 +16193,7 @@
                 <a:ea typeface="Segoe UI Semibold" pitchFamily="34" charset="-122"/>
                 <a:cs typeface="Segoe UI Semibold" pitchFamily="34" charset="-120"/>
               </a:rPr>
-              <a:t>operator</a:t>
+              <a:t>controller</a:t>
             </a:r>
             <a:pPr indent="0" marL="0">
               <a:buNone/>
@@ -16338,7 +16207,7 @@
                 <a:ea typeface="Segoe UI" pitchFamily="34" charset="-122"/>
                 <a:cs typeface="Segoe UI" pitchFamily="34" charset="-120"/>
               </a:rPr>
-              <a:t> is the control plane — it polls subscriptions, persists and de-duplicates events, detects hardware failures and fans out notifications. The </a:t>
+              <a:t> is the data plane — it runs on every node, reads IMDS Scheduled Events, performs the cordon and drain, notifies, and reports every transition to the operator. The </a:t>
             </a:r>
             <a:pPr indent="0" marL="0">
               <a:buNone/>
@@ -16352,7 +16221,7 @@
                 <a:ea typeface="Segoe UI Semibold" pitchFamily="34" charset="-122"/>
                 <a:cs typeface="Segoe UI Semibold" pitchFamily="34" charset="-120"/>
               </a:rPr>
-              <a:t>controller</a:t>
+              <a:t>operator</a:t>
             </a:r>
             <a:pPr indent="0" marL="0">
               <a:buNone/>
@@ -16366,7 +16235,7 @@
                 <a:ea typeface="Segoe UI" pitchFamily="34" charset="-122"/>
                 <a:cs typeface="Segoe UI" pitchFamily="34" charset="-120"/>
               </a:rPr>
-              <a:t> is the data plane — it runs on every node and performs the actual cordon and drain when its node is targeted.</a:t>
+              <a:t> is the control plane — it receives those reports, persists and de-duplicates them, and serves the store, API and dashboard. It polls nothing.</a:t>
             </a:r>
             <a:endParaRPr lang="en-US" sz="1250" dirty="0"/>
           </a:p>
@@ -18048,7 +17917,7 @@
                 <a:ea typeface="Segoe UI Semibold" pitchFamily="34" charset="-122"/>
                 <a:cs typeface="Segoe UI Semibold" pitchFamily="34" charset="-120"/>
               </a:rPr>
-              <a:t>Subscription polling</a:t>
+              <a:t>Fleet-wide report intake</a:t>
             </a:r>
             <a:endParaRPr lang="en-US" sz="1400" dirty="0"/>
           </a:p>
@@ -18087,7 +17956,7 @@
                 <a:ea typeface="Segoe UI" pitchFamily="34" charset="-122"/>
                 <a:cs typeface="Segoe UI" pitchFamily="34" charset="-120"/>
               </a:rPr>
-              <a:t>Sweeps the configured prod/dev subscription lists for maintenance signals — no per-node blind spots.</a:t>
+              <a:t>Every node’s controller POSTs each state transition to /events — one aggregation point across the whole fleet, no polling.</a:t>
             </a:r>
             <a:endParaRPr lang="en-US" sz="1100" dirty="0"/>
           </a:p>
@@ -18387,7 +18256,7 @@
                 <a:ea typeface="Segoe UI" pitchFamily="34" charset="-122"/>
                 <a:cs typeface="Segoe UI" pitchFamily="34" charset="-120"/>
               </a:rPr>
-              <a:t>Every event has a stable ID; repeats increment a counter instead of firing duplicate actions.</a:t>
+              <a:t>Every event has a stable ID; repeat reports increment a counter instead of creating duplicate records.</a:t>
             </a:r>
             <a:endParaRPr lang="en-US" sz="1100" dirty="0"/>
           </a:p>
@@ -18498,7 +18367,7 @@
                 <a:ea typeface="Segoe UI Semibold" pitchFamily="34" charset="-122"/>
                 <a:cs typeface="Segoe UI Semibold" pitchFamily="34" charset="-120"/>
               </a:rPr>
-              <a:t>Hardware-failure detection</a:t>
+              <a:t>IMDS-only — no false triggers</a:t>
             </a:r>
             <a:endParaRPr lang="en-US" sz="1400" dirty="0"/>
           </a:p>
@@ -18537,7 +18406,7 @@
                 <a:ea typeface="Segoe UI" pitchFamily="34" charset="-122"/>
                 <a:cs typeface="Segoe UI" pitchFamily="34" charset="-120"/>
               </a:rPr>
-              <a:t>Flags HardwareDegraded / HardwareFailure, pushes a Teams alert and drives the cordon — gated so a VMSS scale-in never false-triggers.</a:t>
+              <a:t>Tracks only Redeploy / Reboot events the controllers act on. A VMSS scale-in never produces one, so no guardrails are needed.</a:t>
             </a:r>
             <a:endParaRPr lang="en-US" sz="1100" dirty="0"/>
           </a:p>
@@ -18687,7 +18556,7 @@
                 <a:ea typeface="Segoe UI" pitchFamily="34" charset="-122"/>
                 <a:cs typeface="Segoe UI" pitchFamily="34" charset="-120"/>
               </a:rPr>
-              <a:t>Live HTML dashboard and JSON API on :8080 — upcoming actions, event log, health.</a:t>
+              <a:t>Live HTML dashboard and JSON API on :8080 — upcoming actions, event log, dedup counts, audit trail.</a:t>
             </a:r>
             <a:endParaRPr lang="en-US" sz="1100" dirty="0"/>
           </a:p>
@@ -18798,7 +18667,7 @@
                 <a:ea typeface="Segoe UI Semibold" pitchFamily="34" charset="-122"/>
                 <a:cs typeface="Segoe UI Semibold" pitchFamily="34" charset="-120"/>
               </a:rPr>
-              <a:t>Drives the controller</a:t>
+              <a:t>Zero cluster privileges</a:t>
             </a:r>
             <a:endParaRPr lang="en-US" sz="1400" dirty="0"/>
           </a:p>
@@ -18837,7 +18706,7 @@
                 <a:ea typeface="Segoe UI" pitchFamily="34" charset="-122"/>
                 <a:cs typeface="Segoe UI" pitchFamily="34" charset="-120"/>
               </a:rPr>
-              <a:t>Patches the shared node-event ConfigMap so the right node cordons/drains at the right time.</a:t>
+              <a:t>A pure aggregation hub: it polls nothing and makes no Kubernetes API calls — no RBAC beyond its own pod.</a:t>
             </a:r>
             <a:endParaRPr lang="en-US" sz="1100" dirty="0"/>
           </a:p>

</xml_diff>